<commit_message>
Add RAG-based AI tutor and AI presentation generator
</commit_message>
<xml_diff>
--- a/ai_backend/generated_presentation.pptx
+++ b/ai_backend/generated_presentation.pptx
@@ -6,6 +6,10 @@
   </p:sldMasterIdLst>
   <p:sldIdLst>
     <p:sldId id="256" r:id="rId7"/>
+    <p:sldId id="257" r:id="rId8"/>
+    <p:sldId id="258" r:id="rId9"/>
+    <p:sldId id="259" r:id="rId10"/>
+    <p:sldId id="260" r:id="rId11"/>
   </p:sldIdLst>
   <p:sldSz cx="9144000" cy="6858000" type="screen4x3"/>
   <p:notesSz cx="6858000" cy="9144000"/>
@@ -3095,38 +3099,375 @@
             <a:spLocks noGrp="1"/>
           </p:cNvSpPr>
           <p:nvPr>
-            <p:ph type="ctrTitle"/>
-          </p:nvPr>
-        </p:nvSpPr>
-        <p:spPr/>
-        <p:txBody>
-          <a:bodyPr/>
-          <a:lstStyle/>
-          <a:p>
-            <a:r>
-              <a:t>Object-Oriented Programming</a:t>
-            </a:r>
-          </a:p>
-        </p:txBody>
-      </p:sp>
-      <p:sp>
-        <p:nvSpPr>
-          <p:cNvPr id="3" name="Subtitle 2"/>
-          <p:cNvSpPr>
-            <a:spLocks noGrp="1"/>
-          </p:cNvSpPr>
-          <p:nvPr>
-            <p:ph type="subTitle" idx="1"/>
-          </p:nvPr>
-        </p:nvSpPr>
-        <p:spPr/>
-        <p:txBody>
-          <a:bodyPr/>
-          <a:lstStyle/>
-          <a:p>
-            <a:r>
-              <a:t>Generated by EduPath AI</a:t>
-            </a:r>
+            <p:ph type="title"/>
+          </p:nvPr>
+        </p:nvSpPr>
+        <p:spPr/>
+        <p:txBody>
+          <a:bodyPr/>
+          <a:lstStyle/>
+          <a:p>
+            <a:r>
+              <a:t>Untitled</a:t>
+            </a:r>
+          </a:p>
+        </p:txBody>
+      </p:sp>
+      <p:sp>
+        <p:nvSpPr>
+          <p:cNvPr id="3" name="Content Placeholder 2"/>
+          <p:cNvSpPr>
+            <a:spLocks noGrp="1"/>
+          </p:cNvSpPr>
+          <p:nvPr>
+            <p:ph idx="1"/>
+          </p:nvPr>
+        </p:nvSpPr>
+        <p:spPr/>
+        <p:txBody>
+          <a:bodyPr/>
+          <a:lstStyle/>
+          <a:p/>
+          <a:p>
+            <a:pPr/>
+          </a:p>
+        </p:txBody>
+      </p:sp>
+    </p:spTree>
+  </p:cSld>
+  <p:clrMapOvr>
+    <a:masterClrMapping/>
+  </p:clrMapOvr>
+</p:sld>
+</file>
+
+<file path=ppt/slides/slide2.xml><?xml version="1.0" encoding="utf-8"?>
+<p:sld xmlns:a="http://schemas.openxmlformats.org/drawingml/2006/main" xmlns:p="http://schemas.openxmlformats.org/presentationml/2006/main" xmlns:r="http://schemas.openxmlformats.org/officeDocument/2006/relationships">
+  <p:cSld>
+    <p:spTree>
+      <p:nvGrpSpPr>
+        <p:cNvPr id="1" name=""/>
+        <p:cNvGrpSpPr/>
+        <p:nvPr/>
+      </p:nvGrpSpPr>
+      <p:grpSpPr/>
+      <p:sp>
+        <p:nvSpPr>
+          <p:cNvPr id="2" name="Title 1"/>
+          <p:cNvSpPr>
+            <a:spLocks noGrp="1"/>
+          </p:cNvSpPr>
+          <p:nvPr>
+            <p:ph type="title"/>
+          </p:nvPr>
+        </p:nvSpPr>
+        <p:spPr/>
+        <p:txBody>
+          <a:bodyPr/>
+          <a:lstStyle/>
+          <a:p>
+            <a:r>
+              <a:t>Untitled</a:t>
+            </a:r>
+          </a:p>
+        </p:txBody>
+      </p:sp>
+      <p:sp>
+        <p:nvSpPr>
+          <p:cNvPr id="3" name="Content Placeholder 2"/>
+          <p:cNvSpPr>
+            <a:spLocks noGrp="1"/>
+          </p:cNvSpPr>
+          <p:nvPr>
+            <p:ph idx="1"/>
+          </p:nvPr>
+        </p:nvSpPr>
+        <p:spPr/>
+        <p:txBody>
+          <a:bodyPr/>
+          <a:lstStyle/>
+          <a:p/>
+          <a:p>
+            <a:pPr/>
+            <a:r>
+              <a:t>Slide Title: Object-Oriented Programming (OOP)</a:t>
+            </a:r>
+          </a:p>
+          <a:p>
+            <a:pPr/>
+            <a:r>
+              <a:t>Bullet Points:</a:t>
+            </a:r>
+          </a:p>
+          <a:p>
+            <a:pPr/>
+            <a:r>
+              <a:t>Definition: A programming paradigm based on the concept of "objects"</a:t>
+            </a:r>
+          </a:p>
+          <a:p>
+            <a:pPr/>
+            <a:r>
+              <a:t>Objects contain data (attributes) and code (methods)</a:t>
+            </a:r>
+          </a:p>
+          <a:p>
+            <a:pPr/>
+            <a:r>
+              <a:t>Encapsulates data and methods to keep it safe from outside interference</a:t>
+            </a:r>
+          </a:p>
+          <a:p>
+            <a:pPr/>
+          </a:p>
+        </p:txBody>
+      </p:sp>
+    </p:spTree>
+  </p:cSld>
+  <p:clrMapOvr>
+    <a:masterClrMapping/>
+  </p:clrMapOvr>
+</p:sld>
+</file>
+
+<file path=ppt/slides/slide3.xml><?xml version="1.0" encoding="utf-8"?>
+<p:sld xmlns:a="http://schemas.openxmlformats.org/drawingml/2006/main" xmlns:p="http://schemas.openxmlformats.org/presentationml/2006/main" xmlns:r="http://schemas.openxmlformats.org/officeDocument/2006/relationships">
+  <p:cSld>
+    <p:spTree>
+      <p:nvGrpSpPr>
+        <p:cNvPr id="1" name=""/>
+        <p:cNvGrpSpPr/>
+        <p:nvPr/>
+      </p:nvGrpSpPr>
+      <p:grpSpPr/>
+      <p:sp>
+        <p:nvSpPr>
+          <p:cNvPr id="2" name="Title 1"/>
+          <p:cNvSpPr>
+            <a:spLocks noGrp="1"/>
+          </p:cNvSpPr>
+          <p:nvPr>
+            <p:ph type="title"/>
+          </p:nvPr>
+        </p:nvSpPr>
+        <p:spPr/>
+        <p:txBody>
+          <a:bodyPr/>
+          <a:lstStyle/>
+          <a:p>
+            <a:r>
+              <a:t>Untitled</a:t>
+            </a:r>
+          </a:p>
+        </p:txBody>
+      </p:sp>
+      <p:sp>
+        <p:nvSpPr>
+          <p:cNvPr id="3" name="Content Placeholder 2"/>
+          <p:cNvSpPr>
+            <a:spLocks noGrp="1"/>
+          </p:cNvSpPr>
+          <p:nvPr>
+            <p:ph idx="1"/>
+          </p:nvPr>
+        </p:nvSpPr>
+        <p:spPr/>
+        <p:txBody>
+          <a:bodyPr/>
+          <a:lstStyle/>
+          <a:p/>
+          <a:p>
+            <a:pPr/>
+            <a:r>
+              <a:t>Slide Title: Key Concepts in OOP</a:t>
+            </a:r>
+          </a:p>
+          <a:p>
+            <a:pPr/>
+            <a:r>
+              <a:t>Bullet Points:</a:t>
+            </a:r>
+          </a:p>
+          <a:p>
+            <a:pPr/>
+            <a:r>
+              <a:t>Encapsulation: Bundling data with methods operating on that data</a:t>
+            </a:r>
+          </a:p>
+          <a:p>
+            <a:pPr/>
+            <a:r>
+              <a:t>Inheritance: Mechanism where one "child" class inherits attributes and behaviors from a parent class</a:t>
+            </a:r>
+          </a:p>
+          <a:p>
+            <a:pPr/>
+            <a:r>
+              <a:t>Polymorphism: Ability to present different interfaces with clients can interact</a:t>
+            </a:r>
+          </a:p>
+          <a:p>
+            <a:pPr/>
+            <a:r>
+              <a:t>Abstraction: Concept where only necessary details about something need to be represented</a:t>
+            </a:r>
+          </a:p>
+          <a:p>
+            <a:pPr/>
+          </a:p>
+        </p:txBody>
+      </p:sp>
+    </p:spTree>
+  </p:cSld>
+  <p:clrMapOvr>
+    <a:masterClrMapping/>
+  </p:clrMapOvr>
+</p:sld>
+</file>
+
+<file path=ppt/slides/slide4.xml><?xml version="1.0" encoding="utf-8"?>
+<p:sld xmlns:a="http://schemas.openxmlformats.org/drawingml/2006/main" xmlns:p="http://schemas.openxmlformats.org/presentationml/2006/main" xmlns:r="http://schemas.openxmlformats.org/officeDocument/2006/relationships">
+  <p:cSld>
+    <p:spTree>
+      <p:nvGrpSpPr>
+        <p:cNvPr id="1" name=""/>
+        <p:cNvGrpSpPr/>
+        <p:nvPr/>
+      </p:nvGrpSpPr>
+      <p:grpSpPr/>
+      <p:sp>
+        <p:nvSpPr>
+          <p:cNvPr id="2" name="Title 1"/>
+          <p:cNvSpPr>
+            <a:spLocks noGrp="1"/>
+          </p:cNvSpPr>
+          <p:nvPr>
+            <p:ph type="title"/>
+          </p:nvPr>
+        </p:nvSpPr>
+        <p:spPr/>
+        <p:txBody>
+          <a:bodyPr/>
+          <a:lstStyle/>
+          <a:p>
+            <a:r>
+              <a:t>Untitled</a:t>
+            </a:r>
+          </a:p>
+        </p:txBody>
+      </p:sp>
+      <p:sp>
+        <p:nvSpPr>
+          <p:cNvPr id="3" name="Content Placeholder 2"/>
+          <p:cNvSpPr>
+            <a:spLocks noGrp="1"/>
+          </p:cNvSpPr>
+          <p:nvPr>
+            <p:ph idx="1"/>
+          </p:nvPr>
+        </p:nvSpPr>
+        <p:spPr/>
+        <p:txBody>
+          <a:bodyPr/>
+          <a:lstStyle/>
+          <a:p/>
+          <a:p>
+            <a:pPr/>
+            <a:r>
+              <a:t>Slide Title: Encapsulation</a:t>
+            </a:r>
+          </a:p>
+          <a:p>
+            <a:pPr/>
+            <a:r>
+              <a:t>Bullet Points:</a:t>
+            </a:r>
+          </a:p>
+          <a:p>
+            <a:pPr/>
+            <a:r>
+              <a:t>Bundling data with methods operating on that data</a:t>
+            </a:r>
+          </a:p>
+          <a:p>
+            <a:pPr/>
+            <a:r>
+              <a:t>Keeps data safe from outside interference</a:t>
+            </a:r>
+          </a:p>
+          <a:p>
+            <a:pPr/>
+            <a:r>
+              <a:t>Ensures integrity within objects</a:t>
+            </a:r>
+          </a:p>
+          <a:p>
+            <a:pPr/>
+            <a:r>
+              <a:t>Hides properties and ensures they can only be manipulated through defined functions or methods</a:t>
+            </a:r>
+          </a:p>
+          <a:p>
+            <a:pPr/>
+          </a:p>
+        </p:txBody>
+      </p:sp>
+    </p:spTree>
+  </p:cSld>
+  <p:clrMapOvr>
+    <a:masterClrMapping/>
+  </p:clrMapOvr>
+</p:sld>
+</file>
+
+<file path=ppt/slides/slide5.xml><?xml version="1.0" encoding="utf-8"?>
+<p:sld xmlns:a="http://schemas.openxmlformats.org/drawingml/2006/main" xmlns:p="http://schemas.openxmlformats.org/presentationml/2006/main" xmlns:r="http://schemas.openxmlformats.org/officeDocument/2006/relationships">
+  <p:cSld>
+    <p:spTree>
+      <p:nvGrpSpPr>
+        <p:cNvPr id="1" name=""/>
+        <p:cNvGrpSpPr/>
+        <p:nvPr/>
+      </p:nvGrpSpPr>
+      <p:grpSpPr/>
+      <p:sp>
+        <p:nvSpPr>
+          <p:cNvPr id="2" name="Title 1"/>
+          <p:cNvSpPr>
+            <a:spLocks noGrp="1"/>
+          </p:cNvSpPr>
+          <p:nvPr>
+            <p:ph type="title"/>
+          </p:nvPr>
+        </p:nvSpPr>
+        <p:spPr/>
+        <p:txBody>
+          <a:bodyPr/>
+          <a:lstStyle/>
+          <a:p>
+            <a:r>
+              <a:t>Untitled</a:t>
+            </a:r>
+          </a:p>
+        </p:txBody>
+      </p:sp>
+      <p:sp>
+        <p:nvSpPr>
+          <p:cNvPr id="3" name="Content Placeholder 2"/>
+          <p:cNvSpPr>
+            <a:spLocks noGrp="1"/>
+          </p:cNvSpPr>
+          <p:nvPr>
+            <p:ph idx="1"/>
+          </p:nvPr>
+        </p:nvSpPr>
+        <p:spPr/>
+        <p:txBody>
+          <a:bodyPr/>
+          <a:lstStyle/>
+          <a:p/>
+          <a:p>
+            <a:pPr/>
           </a:p>
         </p:txBody>
       </p:sp>

</xml_diff>